<commit_message>
Re sampling compartment dose data.
</commit_message>
<xml_diff>
--- a/Working Documents/2026_COMPAAPM_Figures.pptx
+++ b/Working Documents/2026_COMPAAPM_Figures.pptx
@@ -1788,7 +1788,6 @@
     </c:plotArea>
     <c:plotVisOnly val="1"/>
     <c:dispBlanksAs val="gap"/>
-    <c:showDLblsOverMax val="0"/>
     <c:extLst>
       <c:ext xmlns:c16r3="http://schemas.microsoft.com/office/drawing/2017/03/chart" uri="{56B9EC1D-385E-4148-901F-78D8002777C0}">
         <c16r3:dataDisplayOptions16>
@@ -1796,6 +1795,7 @@
         </c16r3:dataDisplayOptions16>
       </c:ext>
     </c:extLst>
+    <c:showDLblsOverMax val="0"/>
   </c:chart>
   <c:spPr>
     <a:noFill/>
@@ -2512,7 +2512,7 @@
           <a:p>
             <a:fld id="{F350ADBE-E2B5-49AB-99FC-12956E870A1F}" type="datetimeFigureOut">
               <a:rPr lang="en-CA" smtClean="0"/>
-              <a:t>2026-01-13</a:t>
+              <a:t>19-Jan-2026</a:t>
             </a:fld>
             <a:endParaRPr lang="en-CA"/>
           </a:p>
@@ -2712,7 +2712,7 @@
           <a:p>
             <a:fld id="{F350ADBE-E2B5-49AB-99FC-12956E870A1F}" type="datetimeFigureOut">
               <a:rPr lang="en-CA" smtClean="0"/>
-              <a:t>2026-01-13</a:t>
+              <a:t>19-Jan-2026</a:t>
             </a:fld>
             <a:endParaRPr lang="en-CA"/>
           </a:p>
@@ -2922,7 +2922,7 @@
           <a:p>
             <a:fld id="{F350ADBE-E2B5-49AB-99FC-12956E870A1F}" type="datetimeFigureOut">
               <a:rPr lang="en-CA" smtClean="0"/>
-              <a:t>2026-01-13</a:t>
+              <a:t>19-Jan-2026</a:t>
             </a:fld>
             <a:endParaRPr lang="en-CA"/>
           </a:p>
@@ -3122,7 +3122,7 @@
           <a:p>
             <a:fld id="{F350ADBE-E2B5-49AB-99FC-12956E870A1F}" type="datetimeFigureOut">
               <a:rPr lang="en-CA" smtClean="0"/>
-              <a:t>2026-01-13</a:t>
+              <a:t>19-Jan-2026</a:t>
             </a:fld>
             <a:endParaRPr lang="en-CA"/>
           </a:p>
@@ -3398,7 +3398,7 @@
           <a:p>
             <a:fld id="{F350ADBE-E2B5-49AB-99FC-12956E870A1F}" type="datetimeFigureOut">
               <a:rPr lang="en-CA" smtClean="0"/>
-              <a:t>2026-01-13</a:t>
+              <a:t>19-Jan-2026</a:t>
             </a:fld>
             <a:endParaRPr lang="en-CA"/>
           </a:p>
@@ -3666,7 +3666,7 @@
           <a:p>
             <a:fld id="{F350ADBE-E2B5-49AB-99FC-12956E870A1F}" type="datetimeFigureOut">
               <a:rPr lang="en-CA" smtClean="0"/>
-              <a:t>2026-01-13</a:t>
+              <a:t>19-Jan-2026</a:t>
             </a:fld>
             <a:endParaRPr lang="en-CA"/>
           </a:p>
@@ -4081,7 +4081,7 @@
           <a:p>
             <a:fld id="{F350ADBE-E2B5-49AB-99FC-12956E870A1F}" type="datetimeFigureOut">
               <a:rPr lang="en-CA" smtClean="0"/>
-              <a:t>2026-01-13</a:t>
+              <a:t>19-Jan-2026</a:t>
             </a:fld>
             <a:endParaRPr lang="en-CA"/>
           </a:p>
@@ -4223,7 +4223,7 @@
           <a:p>
             <a:fld id="{F350ADBE-E2B5-49AB-99FC-12956E870A1F}" type="datetimeFigureOut">
               <a:rPr lang="en-CA" smtClean="0"/>
-              <a:t>2026-01-13</a:t>
+              <a:t>19-Jan-2026</a:t>
             </a:fld>
             <a:endParaRPr lang="en-CA"/>
           </a:p>
@@ -4336,7 +4336,7 @@
           <a:p>
             <a:fld id="{F350ADBE-E2B5-49AB-99FC-12956E870A1F}" type="datetimeFigureOut">
               <a:rPr lang="en-CA" smtClean="0"/>
-              <a:t>2026-01-13</a:t>
+              <a:t>19-Jan-2026</a:t>
             </a:fld>
             <a:endParaRPr lang="en-CA"/>
           </a:p>
@@ -4649,7 +4649,7 @@
           <a:p>
             <a:fld id="{F350ADBE-E2B5-49AB-99FC-12956E870A1F}" type="datetimeFigureOut">
               <a:rPr lang="en-CA" smtClean="0"/>
-              <a:t>2026-01-13</a:t>
+              <a:t>19-Jan-2026</a:t>
             </a:fld>
             <a:endParaRPr lang="en-CA"/>
           </a:p>
@@ -4938,7 +4938,7 @@
           <a:p>
             <a:fld id="{F350ADBE-E2B5-49AB-99FC-12956E870A1F}" type="datetimeFigureOut">
               <a:rPr lang="en-CA" smtClean="0"/>
-              <a:t>2026-01-13</a:t>
+              <a:t>19-Jan-2026</a:t>
             </a:fld>
             <a:endParaRPr lang="en-CA"/>
           </a:p>
@@ -5181,7 +5181,7 @@
           <a:p>
             <a:fld id="{F350ADBE-E2B5-49AB-99FC-12956E870A1F}" type="datetimeFigureOut">
               <a:rPr lang="en-CA" smtClean="0"/>
-              <a:t>2026-01-13</a:t>
+              <a:t>19-Jan-2026</a:t>
             </a:fld>
             <a:endParaRPr lang="en-CA"/>
           </a:p>
@@ -5600,10 +5600,10 @@
       </p:grpSpPr>
       <p:pic>
         <p:nvPicPr>
-          <p:cNvPr id="3" name="Picture 2">
+          <p:cNvPr id="4" name="Picture 3">
             <a:extLst>
               <a:ext uri="{FF2B5EF4-FFF2-40B4-BE49-F238E27FC236}">
-                <a16:creationId xmlns:a16="http://schemas.microsoft.com/office/drawing/2014/main" id="{6BDCBC90-B634-0417-D665-00AFED56BAF9}"/>
+                <a16:creationId xmlns:a16="http://schemas.microsoft.com/office/drawing/2014/main" id="{4ABD7512-512B-0C92-2838-2937AA8FDACA}"/>
               </a:ext>
             </a:extLst>
           </p:cNvPr>
@@ -5620,8 +5620,8 @@
         </p:blipFill>
         <p:spPr>
           <a:xfrm>
-            <a:off x="2670368" y="2290916"/>
-            <a:ext cx="6615102" cy="2672577"/>
+            <a:off x="2535638" y="2044015"/>
+            <a:ext cx="6856165" cy="2769969"/>
           </a:xfrm>
           <a:prstGeom prst="rect">
             <a:avLst/>
@@ -6012,6 +6012,214 @@
           </a:prstGeom>
         </p:spPr>
       </p:pic>
+      <p:sp>
+        <p:nvSpPr>
+          <p:cNvPr id="4" name="Rectangle 3">
+            <a:extLst>
+              <a:ext uri="{FF2B5EF4-FFF2-40B4-BE49-F238E27FC236}">
+                <a16:creationId xmlns:a16="http://schemas.microsoft.com/office/drawing/2014/main" id="{0A7F124E-722A-2352-39DE-35F1A29F3054}"/>
+              </a:ext>
+            </a:extLst>
+          </p:cNvPr>
+          <p:cNvSpPr/>
+          <p:nvPr/>
+        </p:nvSpPr>
+        <p:spPr>
+          <a:xfrm>
+            <a:off x="1699114" y="2122173"/>
+            <a:ext cx="2273118" cy="776749"/>
+          </a:xfrm>
+          <a:prstGeom prst="rect">
+            <a:avLst/>
+          </a:prstGeom>
+          <a:noFill/>
+          <a:ln w="57150">
+            <a:solidFill>
+              <a:schemeClr val="tx1"/>
+            </a:solidFill>
+          </a:ln>
+        </p:spPr>
+        <p:style>
+          <a:lnRef idx="2">
+            <a:schemeClr val="accent1">
+              <a:shade val="15000"/>
+            </a:schemeClr>
+          </a:lnRef>
+          <a:fillRef idx="1">
+            <a:schemeClr val="accent1"/>
+          </a:fillRef>
+          <a:effectRef idx="0">
+            <a:schemeClr val="accent1"/>
+          </a:effectRef>
+          <a:fontRef idx="minor">
+            <a:schemeClr val="lt1"/>
+          </a:fontRef>
+        </p:style>
+        <p:txBody>
+          <a:bodyPr rtlCol="0" anchor="ctr"/>
+          <a:lstStyle/>
+          <a:p>
+            <a:pPr algn="ctr"/>
+            <a:endParaRPr lang="en-CA"/>
+          </a:p>
+        </p:txBody>
+      </p:sp>
+      <p:sp>
+        <p:nvSpPr>
+          <p:cNvPr id="5" name="Rectangle 4">
+            <a:extLst>
+              <a:ext uri="{FF2B5EF4-FFF2-40B4-BE49-F238E27FC236}">
+                <a16:creationId xmlns:a16="http://schemas.microsoft.com/office/drawing/2014/main" id="{202D1C0C-F508-A3BF-D2BD-176276A9B456}"/>
+              </a:ext>
+            </a:extLst>
+          </p:cNvPr>
+          <p:cNvSpPr/>
+          <p:nvPr/>
+        </p:nvSpPr>
+        <p:spPr>
+          <a:xfrm>
+            <a:off x="7675665" y="2122172"/>
+            <a:ext cx="2273118" cy="776749"/>
+          </a:xfrm>
+          <a:prstGeom prst="rect">
+            <a:avLst/>
+          </a:prstGeom>
+          <a:noFill/>
+          <a:ln w="57150">
+            <a:solidFill>
+              <a:schemeClr val="tx1"/>
+            </a:solidFill>
+          </a:ln>
+        </p:spPr>
+        <p:style>
+          <a:lnRef idx="2">
+            <a:schemeClr val="accent1">
+              <a:shade val="15000"/>
+            </a:schemeClr>
+          </a:lnRef>
+          <a:fillRef idx="1">
+            <a:schemeClr val="accent1"/>
+          </a:fillRef>
+          <a:effectRef idx="0">
+            <a:schemeClr val="accent1"/>
+          </a:effectRef>
+          <a:fontRef idx="minor">
+            <a:schemeClr val="lt1"/>
+          </a:fontRef>
+        </p:style>
+        <p:txBody>
+          <a:bodyPr rtlCol="0" anchor="ctr"/>
+          <a:lstStyle/>
+          <a:p>
+            <a:pPr algn="ctr"/>
+            <a:endParaRPr lang="en-CA"/>
+          </a:p>
+        </p:txBody>
+      </p:sp>
+      <p:sp>
+        <p:nvSpPr>
+          <p:cNvPr id="6" name="Rectangle 5">
+            <a:extLst>
+              <a:ext uri="{FF2B5EF4-FFF2-40B4-BE49-F238E27FC236}">
+                <a16:creationId xmlns:a16="http://schemas.microsoft.com/office/drawing/2014/main" id="{21CB7D3E-A308-DA9F-66DE-C4C219A083D1}"/>
+              </a:ext>
+            </a:extLst>
+          </p:cNvPr>
+          <p:cNvSpPr/>
+          <p:nvPr/>
+        </p:nvSpPr>
+        <p:spPr>
+          <a:xfrm>
+            <a:off x="4862444" y="1055372"/>
+            <a:ext cx="862853" cy="789904"/>
+          </a:xfrm>
+          <a:prstGeom prst="rect">
+            <a:avLst/>
+          </a:prstGeom>
+          <a:noFill/>
+          <a:ln w="57150">
+            <a:solidFill>
+              <a:schemeClr val="tx1"/>
+            </a:solidFill>
+          </a:ln>
+        </p:spPr>
+        <p:style>
+          <a:lnRef idx="2">
+            <a:schemeClr val="accent1">
+              <a:shade val="15000"/>
+            </a:schemeClr>
+          </a:lnRef>
+          <a:fillRef idx="1">
+            <a:schemeClr val="accent1"/>
+          </a:fillRef>
+          <a:effectRef idx="0">
+            <a:schemeClr val="accent1"/>
+          </a:effectRef>
+          <a:fontRef idx="minor">
+            <a:schemeClr val="lt1"/>
+          </a:fontRef>
+        </p:style>
+        <p:txBody>
+          <a:bodyPr rtlCol="0" anchor="ctr"/>
+          <a:lstStyle/>
+          <a:p>
+            <a:pPr algn="ctr"/>
+            <a:endParaRPr lang="en-CA"/>
+          </a:p>
+        </p:txBody>
+      </p:sp>
+      <p:sp>
+        <p:nvSpPr>
+          <p:cNvPr id="9" name="Rectangle 8">
+            <a:extLst>
+              <a:ext uri="{FF2B5EF4-FFF2-40B4-BE49-F238E27FC236}">
+                <a16:creationId xmlns:a16="http://schemas.microsoft.com/office/drawing/2014/main" id="{988A8A81-3959-C3EF-B8E0-8629D6D12386}"/>
+              </a:ext>
+            </a:extLst>
+          </p:cNvPr>
+          <p:cNvSpPr/>
+          <p:nvPr/>
+        </p:nvSpPr>
+        <p:spPr>
+          <a:xfrm>
+            <a:off x="5945720" y="1055372"/>
+            <a:ext cx="862853" cy="789904"/>
+          </a:xfrm>
+          <a:prstGeom prst="rect">
+            <a:avLst/>
+          </a:prstGeom>
+          <a:noFill/>
+          <a:ln w="57150">
+            <a:solidFill>
+              <a:schemeClr val="tx1"/>
+            </a:solidFill>
+          </a:ln>
+        </p:spPr>
+        <p:style>
+          <a:lnRef idx="2">
+            <a:schemeClr val="accent1">
+              <a:shade val="15000"/>
+            </a:schemeClr>
+          </a:lnRef>
+          <a:fillRef idx="1">
+            <a:schemeClr val="accent1"/>
+          </a:fillRef>
+          <a:effectRef idx="0">
+            <a:schemeClr val="accent1"/>
+          </a:effectRef>
+          <a:fontRef idx="minor">
+            <a:schemeClr val="lt1"/>
+          </a:fontRef>
+        </p:style>
+        <p:txBody>
+          <a:bodyPr rtlCol="0" anchor="ctr"/>
+          <a:lstStyle/>
+          <a:p>
+            <a:pPr algn="ctr"/>
+            <a:endParaRPr lang="en-CA"/>
+          </a:p>
+        </p:txBody>
+      </p:sp>
     </p:spTree>
     <p:extLst>
       <p:ext uri="{BB962C8B-B14F-4D97-AF65-F5344CB8AC3E}">
@@ -6064,8 +6272,8 @@
         </p:blipFill>
         <p:spPr>
           <a:xfrm>
-            <a:off x="148092" y="3301180"/>
-            <a:ext cx="4743694" cy="3333921"/>
+            <a:off x="3716488" y="2685168"/>
+            <a:ext cx="3437451" cy="2415879"/>
           </a:xfrm>
           <a:prstGeom prst="roundRect">
             <a:avLst>
@@ -6074,7 +6282,7 @@
           </a:prstGeom>
           <a:ln>
             <a:solidFill>
-              <a:schemeClr val="tx1"/>
+              <a:schemeClr val="bg1"/>
             </a:solidFill>
           </a:ln>
           <a:effectLst/>
@@ -6108,14 +6316,13 @@
         </p:nvPicPr>
         <p:blipFill>
           <a:blip r:embed="rId3"/>
-          <a:stretch>
-            <a:fillRect/>
-          </a:stretch>
+          <a:srcRect r="4638"/>
+          <a:stretch/>
         </p:blipFill>
         <p:spPr>
           <a:xfrm>
-            <a:off x="5100704" y="3301180"/>
-            <a:ext cx="4974421" cy="3333920"/>
+            <a:off x="3627026" y="853207"/>
+            <a:ext cx="3437451" cy="2415879"/>
           </a:xfrm>
           <a:prstGeom prst="roundRect">
             <a:avLst>
@@ -6124,7 +6331,7 @@
           </a:prstGeom>
           <a:ln>
             <a:solidFill>
-              <a:schemeClr val="tx1"/>
+              <a:schemeClr val="bg1"/>
             </a:solidFill>
           </a:ln>
           <a:effectLst/>
@@ -6152,14 +6359,127 @@
         </p:blipFill>
         <p:spPr>
           <a:xfrm>
-            <a:off x="391130" y="2372097"/>
+            <a:off x="3716488" y="5101047"/>
             <a:ext cx="3667637" cy="666843"/>
           </a:xfrm>
           <a:prstGeom prst="rect">
             <a:avLst/>
           </a:prstGeom>
+          <a:ln w="3175">
+            <a:solidFill>
+              <a:schemeClr val="tx1"/>
+            </a:solidFill>
+          </a:ln>
         </p:spPr>
       </p:pic>
+      <p:sp>
+        <p:nvSpPr>
+          <p:cNvPr id="7" name="TextBox 6">
+            <a:extLst>
+              <a:ext uri="{FF2B5EF4-FFF2-40B4-BE49-F238E27FC236}">
+                <a16:creationId xmlns:a16="http://schemas.microsoft.com/office/drawing/2014/main" id="{6E557ECB-1764-81FB-14D6-1678B789ED63}"/>
+              </a:ext>
+            </a:extLst>
+          </p:cNvPr>
+          <p:cNvSpPr txBox="1"/>
+          <p:nvPr/>
+        </p:nvSpPr>
+        <p:spPr>
+          <a:xfrm>
+            <a:off x="3279086" y="919038"/>
+            <a:ext cx="455574" cy="369332"/>
+          </a:xfrm>
+          <a:prstGeom prst="rect">
+            <a:avLst/>
+          </a:prstGeom>
+          <a:noFill/>
+        </p:spPr>
+        <p:txBody>
+          <a:bodyPr wrap="none" rtlCol="0">
+            <a:spAutoFit/>
+          </a:bodyPr>
+          <a:lstStyle/>
+          <a:p>
+            <a:r>
+              <a:rPr lang="en-US" dirty="0"/>
+              <a:t>(A)</a:t>
+            </a:r>
+            <a:endParaRPr lang="en-CA" dirty="0"/>
+          </a:p>
+        </p:txBody>
+      </p:sp>
+      <p:sp>
+        <p:nvSpPr>
+          <p:cNvPr id="8" name="TextBox 7">
+            <a:extLst>
+              <a:ext uri="{FF2B5EF4-FFF2-40B4-BE49-F238E27FC236}">
+                <a16:creationId xmlns:a16="http://schemas.microsoft.com/office/drawing/2014/main" id="{A5403CC2-CCCE-703E-6506-53B8AB0C2B64}"/>
+              </a:ext>
+            </a:extLst>
+          </p:cNvPr>
+          <p:cNvSpPr txBox="1"/>
+          <p:nvPr/>
+        </p:nvSpPr>
+        <p:spPr>
+          <a:xfrm>
+            <a:off x="3281343" y="3084420"/>
+            <a:ext cx="458780" cy="369332"/>
+          </a:xfrm>
+          <a:prstGeom prst="rect">
+            <a:avLst/>
+          </a:prstGeom>
+          <a:noFill/>
+        </p:spPr>
+        <p:txBody>
+          <a:bodyPr wrap="none" rtlCol="0">
+            <a:spAutoFit/>
+          </a:bodyPr>
+          <a:lstStyle/>
+          <a:p>
+            <a:r>
+              <a:rPr lang="en-US" dirty="0"/>
+              <a:t>(B)</a:t>
+            </a:r>
+            <a:endParaRPr lang="en-CA" dirty="0"/>
+          </a:p>
+        </p:txBody>
+      </p:sp>
+      <p:sp>
+        <p:nvSpPr>
+          <p:cNvPr id="9" name="TextBox 8">
+            <a:extLst>
+              <a:ext uri="{FF2B5EF4-FFF2-40B4-BE49-F238E27FC236}">
+                <a16:creationId xmlns:a16="http://schemas.microsoft.com/office/drawing/2014/main" id="{463BD8ED-31AD-9297-4635-5F21613CAE03}"/>
+              </a:ext>
+            </a:extLst>
+          </p:cNvPr>
+          <p:cNvSpPr txBox="1"/>
+          <p:nvPr/>
+        </p:nvSpPr>
+        <p:spPr>
+          <a:xfrm>
+            <a:off x="3267064" y="4738819"/>
+            <a:ext cx="479618" cy="369332"/>
+          </a:xfrm>
+          <a:prstGeom prst="rect">
+            <a:avLst/>
+          </a:prstGeom>
+          <a:noFill/>
+        </p:spPr>
+        <p:txBody>
+          <a:bodyPr wrap="none" rtlCol="0">
+            <a:spAutoFit/>
+          </a:bodyPr>
+          <a:lstStyle/>
+          <a:p>
+            <a:r>
+              <a:rPr lang="en-US" dirty="0"/>
+              <a:t>(C)</a:t>
+            </a:r>
+            <a:endParaRPr lang="en-CA" dirty="0"/>
+          </a:p>
+        </p:txBody>
+      </p:sp>
     </p:spTree>
     <p:extLst>
       <p:ext uri="{BB962C8B-B14F-4D97-AF65-F5344CB8AC3E}">
@@ -6931,7 +7251,7 @@
           <p:nvPr>
             <p:extLst>
               <p:ext uri="{D42A27DB-BD31-4B8C-83A1-F6EECF244321}">
-                <p14:modId xmlns:p14="http://schemas.microsoft.com/office/powerpoint/2010/main" val="2095867461"/>
+                <p14:modId xmlns:p14="http://schemas.microsoft.com/office/powerpoint/2010/main" val="1020949822"/>
               </p:ext>
             </p:extLst>
           </p:nvPr>
@@ -6946,8 +7266,8 @@
           </a:graphicData>
         </a:graphic>
       </p:graphicFrame>
-      <mc:AlternateContent xmlns:mc="http://schemas.openxmlformats.org/markup-compatibility/2006">
-        <mc:Choice xmlns:a14="http://schemas.microsoft.com/office/drawing/2010/main" Requires="a14">
+      <mc:AlternateContent xmlns:mc="http://schemas.openxmlformats.org/markup-compatibility/2006" xmlns:a14="http://schemas.microsoft.com/office/drawing/2010/main">
+        <mc:Choice Requires="a14">
           <p:sp>
             <p:nvSpPr>
               <p:cNvPr id="7" name="TextBox 6">
@@ -6976,6 +7296,7 @@
               </a:bodyPr>
               <a:lstStyle/>
               <a:p>
+                <a:pPr/>
                 <a14:m>
                   <m:oMathPara xmlns:m="http://schemas.openxmlformats.org/officeDocument/2006/math">
                     <m:oMathParaPr>
@@ -7015,7 +7336,7 @@
             </p:txBody>
           </p:sp>
         </mc:Choice>
-        <mc:Fallback>
+        <mc:Fallback xmlns="">
           <p:sp>
             <p:nvSpPr>
               <p:cNvPr id="7" name="TextBox 6">
@@ -7104,8 +7425,8 @@
           </a:fontRef>
         </p:style>
       </p:cxnSp>
-      <mc:AlternateContent xmlns:mc="http://schemas.openxmlformats.org/markup-compatibility/2006">
-        <mc:Choice xmlns:a14="http://schemas.microsoft.com/office/drawing/2010/main" Requires="a14">
+      <mc:AlternateContent xmlns:mc="http://schemas.openxmlformats.org/markup-compatibility/2006" xmlns:a14="http://schemas.microsoft.com/office/drawing/2010/main">
+        <mc:Choice Requires="a14">
           <p:sp>
             <p:nvSpPr>
               <p:cNvPr id="10" name="TextBox 9">
@@ -7134,6 +7455,7 @@
               </a:bodyPr>
               <a:lstStyle/>
               <a:p>
+                <a:pPr/>
                 <a14:m>
                   <m:oMathPara xmlns:m="http://schemas.openxmlformats.org/officeDocument/2006/math">
                     <m:oMathParaPr>
@@ -7186,7 +7508,7 @@
             </p:txBody>
           </p:sp>
         </mc:Choice>
-        <mc:Fallback>
+        <mc:Fallback xmlns="">
           <p:sp>
             <p:nvSpPr>
               <p:cNvPr id="10" name="TextBox 9">
@@ -7319,8 +7641,8 @@
           </a:p>
         </p:txBody>
       </p:sp>
-      <mc:AlternateContent xmlns:mc="http://schemas.openxmlformats.org/markup-compatibility/2006">
-        <mc:Choice xmlns:a14="http://schemas.microsoft.com/office/drawing/2010/main" Requires="a14">
+      <mc:AlternateContent xmlns:mc="http://schemas.openxmlformats.org/markup-compatibility/2006" xmlns:a14="http://schemas.microsoft.com/office/drawing/2010/main">
+        <mc:Choice Requires="a14">
           <p:sp>
             <p:nvSpPr>
               <p:cNvPr id="17" name="TextBox 16">
@@ -7349,6 +7671,7 @@
               </a:bodyPr>
               <a:lstStyle/>
               <a:p>
+                <a:pPr/>
                 <a14:m>
                   <m:oMathPara xmlns:m="http://schemas.openxmlformats.org/officeDocument/2006/math">
                     <m:oMathParaPr>
@@ -7428,7 +7751,7 @@
             </p:txBody>
           </p:sp>
         </mc:Choice>
-        <mc:Fallback>
+        <mc:Fallback xmlns="">
           <p:sp>
             <p:nvSpPr>
               <p:cNvPr id="17" name="TextBox 16">
@@ -7608,8 +7931,8 @@
           </a:fontRef>
         </p:style>
       </p:cxnSp>
-      <mc:AlternateContent xmlns:mc="http://schemas.openxmlformats.org/markup-compatibility/2006">
-        <mc:Choice xmlns:a14="http://schemas.microsoft.com/office/drawing/2010/main" Requires="a14">
+      <mc:AlternateContent xmlns:mc="http://schemas.openxmlformats.org/markup-compatibility/2006" xmlns:a14="http://schemas.microsoft.com/office/drawing/2010/main">
+        <mc:Choice Requires="a14">
           <p:sp>
             <p:nvSpPr>
               <p:cNvPr id="22" name="TextBox 21">
@@ -7638,6 +7961,7 @@
               </a:bodyPr>
               <a:lstStyle/>
               <a:p>
+                <a:pPr/>
                 <a14:m>
                   <m:oMathPara xmlns:m="http://schemas.openxmlformats.org/officeDocument/2006/math">
                     <m:oMathParaPr>
@@ -7677,7 +8001,7 @@
             </p:txBody>
           </p:sp>
         </mc:Choice>
-        <mc:Fallback>
+        <mc:Fallback xmlns="">
           <p:sp>
             <p:nvSpPr>
               <p:cNvPr id="22" name="TextBox 21">
@@ -7722,8 +8046,8 @@
           </p:sp>
         </mc:Fallback>
       </mc:AlternateContent>
-      <mc:AlternateContent xmlns:mc="http://schemas.openxmlformats.org/markup-compatibility/2006">
-        <mc:Choice xmlns:a14="http://schemas.microsoft.com/office/drawing/2010/main" Requires="a14">
+      <mc:AlternateContent xmlns:mc="http://schemas.openxmlformats.org/markup-compatibility/2006" xmlns:a14="http://schemas.microsoft.com/office/drawing/2010/main">
+        <mc:Choice Requires="a14">
           <p:sp>
             <p:nvSpPr>
               <p:cNvPr id="25" name="TextBox 24">
@@ -7782,7 +8106,7 @@
             </p:txBody>
           </p:sp>
         </mc:Choice>
-        <mc:Fallback>
+        <mc:Fallback xmlns="">
           <p:sp>
             <p:nvSpPr>
               <p:cNvPr id="25" name="TextBox 24">
@@ -7844,14 +8168,14 @@
               <p:nvPr>
                 <p:extLst>
                   <p:ext uri="{D42A27DB-BD31-4B8C-83A1-F6EECF244321}">
-                    <p14:modId xmlns:p14="http://schemas.microsoft.com/office/powerpoint/2010/main" val="2163234302"/>
+                    <p14:modId xmlns:p14="http://schemas.microsoft.com/office/powerpoint/2010/main" val="1877467923"/>
                   </p:ext>
                 </p:extLst>
               </p:nvPr>
             </p:nvGraphicFramePr>
             <p:xfrm>
               <a:off x="6541652" y="3392443"/>
-              <a:ext cx="2369124" cy="1831855"/>
+              <a:ext cx="2369124" cy="1853279"/>
             </p:xfrm>
             <a:graphic>
               <a:graphicData uri="http://schemas.openxmlformats.org/drawingml/2006/table">
@@ -7961,6 +8285,7 @@
                         <a:bodyPr/>
                         <a:lstStyle/>
                         <a:p>
+                          <a:pPr/>
                           <a14:m>
                             <m:oMathPara xmlns:m="http://schemas.openxmlformats.org/officeDocument/2006/math">
                               <m:oMathParaPr>
@@ -8037,6 +8362,7 @@
                         <a:bodyPr/>
                         <a:lstStyle/>
                         <a:p>
+                          <a:pPr/>
                           <a14:m>
                             <m:oMathPara xmlns:m="http://schemas.openxmlformats.org/officeDocument/2006/math">
                               <m:oMathParaPr>
@@ -8581,10 +8907,10 @@
                                   </m:e>
                                   <m:sub>
                                     <m:r>
-                                      <a:rPr lang="en-CA" b="0" i="1" smtClean="0">
+                                      <a:rPr lang="en-US" b="0" i="1" smtClean="0">
                                         <a:latin typeface="Cambria Math" panose="02040503050406030204" pitchFamily="18" charset="0"/>
                                       </a:rPr>
-                                      <m:t>𝑖</m:t>
+                                      <m:t>𝑓</m:t>
                                     </m:r>
                                   </m:sub>
                                 </m:sSub>
@@ -8651,7 +8977,7 @@
                                 <m:sSub>
                                   <m:sSubPr>
                                     <m:ctrlPr>
-                                      <a:rPr lang="en-CA" b="0" i="1" smtClean="0">
+                                      <a:rPr lang="en-CA" sz="1400" b="0" i="1" smtClean="0">
                                         <a:solidFill>
                                           <a:schemeClr val="tx1"/>
                                         </a:solidFill>
@@ -8661,7 +8987,7 @@
                                   </m:sSubPr>
                                   <m:e>
                                     <m:r>
-                                      <a:rPr lang="en-CA" b="0" i="1" smtClean="0">
+                                      <a:rPr lang="en-CA" sz="1400" b="0" i="1" smtClean="0">
                                         <a:solidFill>
                                           <a:schemeClr val="tx1"/>
                                         </a:solidFill>
@@ -8672,7 +8998,7 @@
                                   </m:e>
                                   <m:sub>
                                     <m:r>
-                                      <a:rPr lang="en-CA" b="0" i="1" smtClean="0">
+                                      <a:rPr lang="en-US" sz="1400" b="0" i="1" smtClean="0">
                                         <a:solidFill>
                                           <a:schemeClr val="tx1"/>
                                         </a:solidFill>
@@ -8680,8 +9006,46 @@
                                       </a:rPr>
                                       <m:t>𝑖</m:t>
                                     </m:r>
+                                    <m:r>
+                                      <a:rPr lang="en-US" sz="1400" b="0" i="1" smtClean="0">
+                                        <a:solidFill>
+                                          <a:schemeClr val="tx1"/>
+                                        </a:solidFill>
+                                        <a:latin typeface="Cambria Math" panose="02040503050406030204" pitchFamily="18" charset="0"/>
+                                      </a:rPr>
+                                      <m:t> </m:t>
+                                    </m:r>
                                   </m:sub>
                                 </m:sSub>
+                                <m:r>
+                                  <a:rPr lang="en-US" sz="1400" b="0" i="1" smtClean="0">
+                                    <a:solidFill>
+                                      <a:schemeClr val="tx1"/>
+                                    </a:solidFill>
+                                    <a:latin typeface="Cambria Math" panose="02040503050406030204" pitchFamily="18" charset="0"/>
+                                  </a:rPr>
+                                  <m:t>+ </m:t>
+                                </m:r>
+                                <m:r>
+                                  <a:rPr lang="en-US" sz="1400" b="0" i="1" smtClean="0">
+                                    <a:solidFill>
+                                      <a:schemeClr val="tx1"/>
+                                    </a:solidFill>
+                                    <a:latin typeface="Cambria Math" panose="02040503050406030204" pitchFamily="18" charset="0"/>
+                                    <a:ea typeface="Cambria Math" panose="02040503050406030204" pitchFamily="18" charset="0"/>
+                                  </a:rPr>
+                                  <m:t>∆</m:t>
+                                </m:r>
+                                <m:r>
+                                  <a:rPr lang="en-US" sz="1400" b="0" i="1" smtClean="0">
+                                    <a:solidFill>
+                                      <a:schemeClr val="tx1"/>
+                                    </a:solidFill>
+                                    <a:latin typeface="Cambria Math" panose="02040503050406030204" pitchFamily="18" charset="0"/>
+                                    <a:ea typeface="Cambria Math" panose="02040503050406030204" pitchFamily="18" charset="0"/>
+                                  </a:rPr>
+                                  <m:t>𝑡</m:t>
+                                </m:r>
                               </m:oMath>
                             </m:oMathPara>
                           </a14:m>
@@ -9059,14 +9423,14 @@
               <p:nvPr>
                 <p:extLst>
                   <p:ext uri="{D42A27DB-BD31-4B8C-83A1-F6EECF244321}">
-                    <p14:modId xmlns:p14="http://schemas.microsoft.com/office/powerpoint/2010/main" val="2163234302"/>
+                    <p14:modId xmlns:p14="http://schemas.microsoft.com/office/powerpoint/2010/main" val="1877467923"/>
                   </p:ext>
                 </p:extLst>
               </p:nvPr>
             </p:nvGraphicFramePr>
             <p:xfrm>
               <a:off x="6541652" y="3392443"/>
-              <a:ext cx="2369124" cy="1831855"/>
+              <a:ext cx="2369124" cy="1853279"/>
             </p:xfrm>
             <a:graphic>
               <a:graphicData uri="http://schemas.openxmlformats.org/drawingml/2006/table">
@@ -9142,7 +9506,7 @@
                         <a:blipFill>
                           <a:blip r:embed="rId8"/>
                           <a:stretch>
-                            <a:fillRect r="-200769" b="-430000"/>
+                            <a:fillRect r="-200769" b="-435000"/>
                           </a:stretch>
                         </a:blipFill>
                       </a:tcPr>
@@ -9197,7 +9561,7 @@
                         <a:blipFill>
                           <a:blip r:embed="rId8"/>
                           <a:stretch>
-                            <a:fillRect l="-100775" r="-102326" b="-430000"/>
+                            <a:fillRect l="-100775" r="-102326" b="-435000"/>
                           </a:stretch>
                         </a:blipFill>
                       </a:tcPr>
@@ -9246,7 +9610,7 @@
                         <a:blipFill>
                           <a:blip r:embed="rId8"/>
                           <a:stretch>
-                            <a:fillRect l="-199231" r="-1538" b="-430000"/>
+                            <a:fillRect l="-199231" r="-1538" b="-435000"/>
                           </a:stretch>
                         </a:blipFill>
                       </a:tcPr>
@@ -9687,7 +10051,7 @@
                       </a:ext>
                     </a:extLst>
                   </a:tr>
-                  <a:tr h="366371">
+                  <a:tr h="387795">
                     <a:tc>
                       <a:txBody>
                         <a:bodyPr/>
@@ -9738,7 +10102,7 @@
                         <a:blipFill>
                           <a:blip r:embed="rId8"/>
                           <a:stretch>
-                            <a:fillRect t="-296721" r="-200769" b="-124590"/>
+                            <a:fillRect t="-282813" r="-200769" b="-118750"/>
                           </a:stretch>
                         </a:blipFill>
                       </a:tcPr>
@@ -9799,7 +10163,7 @@
                         <a:blipFill>
                           <a:blip r:embed="rId8"/>
                           <a:stretch>
-                            <a:fillRect l="-100775" t="-296721" r="-102326" b="-124590"/>
+                            <a:fillRect l="-100775" t="-282813" r="-102326" b="-118750"/>
                           </a:stretch>
                         </a:blipFill>
                       </a:tcPr>
@@ -9854,7 +10218,7 @@
                         <a:blipFill>
                           <a:blip r:embed="rId8"/>
                           <a:stretch>
-                            <a:fillRect l="-199231" t="-296721" r="-1538" b="-124590"/>
+                            <a:fillRect l="-199231" t="-282813" r="-1538" b="-118750"/>
                           </a:stretch>
                         </a:blipFill>
                       </a:tcPr>
@@ -10190,12 +10554,17 @@
         </p:blipFill>
         <p:spPr>
           <a:xfrm>
-            <a:off x="3294689" y="830988"/>
+            <a:off x="2758978" y="5857323"/>
             <a:ext cx="5487166" cy="600159"/>
           </a:xfrm>
           <a:prstGeom prst="rect">
             <a:avLst/>
           </a:prstGeom>
+          <a:ln w="3175">
+            <a:solidFill>
+              <a:schemeClr val="tx1"/>
+            </a:solidFill>
+          </a:ln>
         </p:spPr>
       </p:pic>
       <p:cxnSp>
@@ -10212,7 +10581,7 @@
         </p:nvCxnSpPr>
         <p:spPr>
           <a:xfrm>
-            <a:off x="2752436" y="2842759"/>
+            <a:off x="2948710" y="2870479"/>
             <a:ext cx="392548" cy="0"/>
           </a:xfrm>
           <a:prstGeom prst="straightConnector1">
@@ -10254,7 +10623,7 @@
         </p:nvSpPr>
         <p:spPr>
           <a:xfrm>
-            <a:off x="2057264" y="2704260"/>
+            <a:off x="2263320" y="2731980"/>
             <a:ext cx="720710" cy="276999"/>
           </a:xfrm>
           <a:prstGeom prst="rect">
@@ -10272,6 +10641,150 @@
               <a:rPr lang="en-CA" sz="1200" dirty="0"/>
               <a:t>Position</a:t>
             </a:r>
+          </a:p>
+        </p:txBody>
+      </p:sp>
+      <p:sp>
+        <p:nvSpPr>
+          <p:cNvPr id="2" name="TextBox 1">
+            <a:extLst>
+              <a:ext uri="{FF2B5EF4-FFF2-40B4-BE49-F238E27FC236}">
+                <a16:creationId xmlns:a16="http://schemas.microsoft.com/office/drawing/2014/main" id="{7B62D037-1D21-4472-A415-1A5D4D3050AE}"/>
+              </a:ext>
+            </a:extLst>
+          </p:cNvPr>
+          <p:cNvSpPr txBox="1"/>
+          <p:nvPr/>
+        </p:nvSpPr>
+        <p:spPr>
+          <a:xfrm>
+            <a:off x="2052097" y="1993288"/>
+            <a:ext cx="455574" cy="369332"/>
+          </a:xfrm>
+          <a:prstGeom prst="rect">
+            <a:avLst/>
+          </a:prstGeom>
+          <a:noFill/>
+        </p:spPr>
+        <p:txBody>
+          <a:bodyPr wrap="none" rtlCol="0">
+            <a:spAutoFit/>
+          </a:bodyPr>
+          <a:lstStyle/>
+          <a:p>
+            <a:r>
+              <a:rPr lang="en-US" dirty="0"/>
+              <a:t>(A)</a:t>
+            </a:r>
+            <a:endParaRPr lang="en-CA" dirty="0"/>
+          </a:p>
+        </p:txBody>
+      </p:sp>
+      <p:sp>
+        <p:nvSpPr>
+          <p:cNvPr id="4" name="TextBox 3">
+            <a:extLst>
+              <a:ext uri="{FF2B5EF4-FFF2-40B4-BE49-F238E27FC236}">
+                <a16:creationId xmlns:a16="http://schemas.microsoft.com/office/drawing/2014/main" id="{E48626D6-A000-AB31-3690-C47F86DC4525}"/>
+              </a:ext>
+            </a:extLst>
+          </p:cNvPr>
+          <p:cNvSpPr txBox="1"/>
+          <p:nvPr/>
+        </p:nvSpPr>
+        <p:spPr>
+          <a:xfrm>
+            <a:off x="2052865" y="3129052"/>
+            <a:ext cx="458780" cy="369332"/>
+          </a:xfrm>
+          <a:prstGeom prst="rect">
+            <a:avLst/>
+          </a:prstGeom>
+          <a:noFill/>
+        </p:spPr>
+        <p:txBody>
+          <a:bodyPr wrap="none" rtlCol="0">
+            <a:spAutoFit/>
+          </a:bodyPr>
+          <a:lstStyle/>
+          <a:p>
+            <a:r>
+              <a:rPr lang="en-US" dirty="0"/>
+              <a:t>(B)</a:t>
+            </a:r>
+            <a:endParaRPr lang="en-CA" dirty="0"/>
+          </a:p>
+        </p:txBody>
+      </p:sp>
+      <p:sp>
+        <p:nvSpPr>
+          <p:cNvPr id="9" name="TextBox 8">
+            <a:extLst>
+              <a:ext uri="{FF2B5EF4-FFF2-40B4-BE49-F238E27FC236}">
+                <a16:creationId xmlns:a16="http://schemas.microsoft.com/office/drawing/2014/main" id="{AA8259E5-8381-839D-235A-4C96EB5F5F25}"/>
+              </a:ext>
+            </a:extLst>
+          </p:cNvPr>
+          <p:cNvSpPr txBox="1"/>
+          <p:nvPr/>
+        </p:nvSpPr>
+        <p:spPr>
+          <a:xfrm>
+            <a:off x="5798463" y="3123860"/>
+            <a:ext cx="479618" cy="369332"/>
+          </a:xfrm>
+          <a:prstGeom prst="rect">
+            <a:avLst/>
+          </a:prstGeom>
+          <a:noFill/>
+        </p:spPr>
+        <p:txBody>
+          <a:bodyPr wrap="none" rtlCol="0">
+            <a:spAutoFit/>
+          </a:bodyPr>
+          <a:lstStyle/>
+          <a:p>
+            <a:r>
+              <a:rPr lang="en-US" dirty="0"/>
+              <a:t>(C)</a:t>
+            </a:r>
+            <a:endParaRPr lang="en-CA" dirty="0"/>
+          </a:p>
+        </p:txBody>
+      </p:sp>
+      <p:sp>
+        <p:nvSpPr>
+          <p:cNvPr id="11" name="TextBox 10">
+            <a:extLst>
+              <a:ext uri="{FF2B5EF4-FFF2-40B4-BE49-F238E27FC236}">
+                <a16:creationId xmlns:a16="http://schemas.microsoft.com/office/drawing/2014/main" id="{2F4D52F0-A9F8-01F6-4E16-2CC027DB62AA}"/>
+              </a:ext>
+            </a:extLst>
+          </p:cNvPr>
+          <p:cNvSpPr txBox="1"/>
+          <p:nvPr/>
+        </p:nvSpPr>
+        <p:spPr>
+          <a:xfrm>
+            <a:off x="2024312" y="5803705"/>
+            <a:ext cx="478016" cy="369332"/>
+          </a:xfrm>
+          <a:prstGeom prst="rect">
+            <a:avLst/>
+          </a:prstGeom>
+          <a:noFill/>
+        </p:spPr>
+        <p:txBody>
+          <a:bodyPr wrap="none" rtlCol="0">
+            <a:spAutoFit/>
+          </a:bodyPr>
+          <a:lstStyle/>
+          <a:p>
+            <a:r>
+              <a:rPr lang="en-US" dirty="0"/>
+              <a:t>(D)</a:t>
+            </a:r>
+            <a:endParaRPr lang="en-CA" dirty="0"/>
           </a:p>
         </p:txBody>
       </p:sp>

</xml_diff>

<commit_message>
In office dose generation
</commit_message>
<xml_diff>
--- a/Working Documents/2026_COMPAAPM_Figures.pptx
+++ b/Working Documents/2026_COMPAAPM_Figures.pptx
@@ -6,13 +6,14 @@
   </p:sldMasterIdLst>
   <p:sldIdLst>
     <p:sldId id="258" r:id="rId2"/>
-    <p:sldId id="259" r:id="rId3"/>
-    <p:sldId id="261" r:id="rId4"/>
-    <p:sldId id="263" r:id="rId5"/>
-    <p:sldId id="264" r:id="rId6"/>
-    <p:sldId id="265" r:id="rId7"/>
-    <p:sldId id="257" r:id="rId8"/>
-    <p:sldId id="260" r:id="rId9"/>
+    <p:sldId id="266" r:id="rId3"/>
+    <p:sldId id="259" r:id="rId4"/>
+    <p:sldId id="261" r:id="rId5"/>
+    <p:sldId id="263" r:id="rId6"/>
+    <p:sldId id="264" r:id="rId7"/>
+    <p:sldId id="265" r:id="rId8"/>
+    <p:sldId id="257" r:id="rId9"/>
+    <p:sldId id="260" r:id="rId10"/>
   </p:sldIdLst>
   <p:sldSz cx="12192000" cy="6858000"/>
   <p:notesSz cx="6858000" cy="9144000"/>
@@ -2512,7 +2513,7 @@
           <a:p>
             <a:fld id="{F350ADBE-E2B5-49AB-99FC-12956E870A1F}" type="datetimeFigureOut">
               <a:rPr lang="en-CA" smtClean="0"/>
-              <a:t>19-Jan-2026</a:t>
+              <a:t>26-Jan-2026</a:t>
             </a:fld>
             <a:endParaRPr lang="en-CA"/>
           </a:p>
@@ -2712,7 +2713,7 @@
           <a:p>
             <a:fld id="{F350ADBE-E2B5-49AB-99FC-12956E870A1F}" type="datetimeFigureOut">
               <a:rPr lang="en-CA" smtClean="0"/>
-              <a:t>19-Jan-2026</a:t>
+              <a:t>26-Jan-2026</a:t>
             </a:fld>
             <a:endParaRPr lang="en-CA"/>
           </a:p>
@@ -2922,7 +2923,7 @@
           <a:p>
             <a:fld id="{F350ADBE-E2B5-49AB-99FC-12956E870A1F}" type="datetimeFigureOut">
               <a:rPr lang="en-CA" smtClean="0"/>
-              <a:t>19-Jan-2026</a:t>
+              <a:t>26-Jan-2026</a:t>
             </a:fld>
             <a:endParaRPr lang="en-CA"/>
           </a:p>
@@ -3122,7 +3123,7 @@
           <a:p>
             <a:fld id="{F350ADBE-E2B5-49AB-99FC-12956E870A1F}" type="datetimeFigureOut">
               <a:rPr lang="en-CA" smtClean="0"/>
-              <a:t>19-Jan-2026</a:t>
+              <a:t>26-Jan-2026</a:t>
             </a:fld>
             <a:endParaRPr lang="en-CA"/>
           </a:p>
@@ -3398,7 +3399,7 @@
           <a:p>
             <a:fld id="{F350ADBE-E2B5-49AB-99FC-12956E870A1F}" type="datetimeFigureOut">
               <a:rPr lang="en-CA" smtClean="0"/>
-              <a:t>19-Jan-2026</a:t>
+              <a:t>26-Jan-2026</a:t>
             </a:fld>
             <a:endParaRPr lang="en-CA"/>
           </a:p>
@@ -3666,7 +3667,7 @@
           <a:p>
             <a:fld id="{F350ADBE-E2B5-49AB-99FC-12956E870A1F}" type="datetimeFigureOut">
               <a:rPr lang="en-CA" smtClean="0"/>
-              <a:t>19-Jan-2026</a:t>
+              <a:t>26-Jan-2026</a:t>
             </a:fld>
             <a:endParaRPr lang="en-CA"/>
           </a:p>
@@ -4081,7 +4082,7 @@
           <a:p>
             <a:fld id="{F350ADBE-E2B5-49AB-99FC-12956E870A1F}" type="datetimeFigureOut">
               <a:rPr lang="en-CA" smtClean="0"/>
-              <a:t>19-Jan-2026</a:t>
+              <a:t>26-Jan-2026</a:t>
             </a:fld>
             <a:endParaRPr lang="en-CA"/>
           </a:p>
@@ -4223,7 +4224,7 @@
           <a:p>
             <a:fld id="{F350ADBE-E2B5-49AB-99FC-12956E870A1F}" type="datetimeFigureOut">
               <a:rPr lang="en-CA" smtClean="0"/>
-              <a:t>19-Jan-2026</a:t>
+              <a:t>26-Jan-2026</a:t>
             </a:fld>
             <a:endParaRPr lang="en-CA"/>
           </a:p>
@@ -4336,7 +4337,7 @@
           <a:p>
             <a:fld id="{F350ADBE-E2B5-49AB-99FC-12956E870A1F}" type="datetimeFigureOut">
               <a:rPr lang="en-CA" smtClean="0"/>
-              <a:t>19-Jan-2026</a:t>
+              <a:t>26-Jan-2026</a:t>
             </a:fld>
             <a:endParaRPr lang="en-CA"/>
           </a:p>
@@ -4649,7 +4650,7 @@
           <a:p>
             <a:fld id="{F350ADBE-E2B5-49AB-99FC-12956E870A1F}" type="datetimeFigureOut">
               <a:rPr lang="en-CA" smtClean="0"/>
-              <a:t>19-Jan-2026</a:t>
+              <a:t>26-Jan-2026</a:t>
             </a:fld>
             <a:endParaRPr lang="en-CA"/>
           </a:p>
@@ -4938,7 +4939,7 @@
           <a:p>
             <a:fld id="{F350ADBE-E2B5-49AB-99FC-12956E870A1F}" type="datetimeFigureOut">
               <a:rPr lang="en-CA" smtClean="0"/>
-              <a:t>19-Jan-2026</a:t>
+              <a:t>26-Jan-2026</a:t>
             </a:fld>
             <a:endParaRPr lang="en-CA"/>
           </a:p>
@@ -5181,7 +5182,7 @@
           <a:p>
             <a:fld id="{F350ADBE-E2B5-49AB-99FC-12956E870A1F}" type="datetimeFigureOut">
               <a:rPr lang="en-CA" smtClean="0"/>
-              <a:t>19-Jan-2026</a:t>
+              <a:t>26-Jan-2026</a:t>
             </a:fld>
             <a:endParaRPr lang="en-CA"/>
           </a:p>
@@ -5660,6 +5661,66 @@
       </p:grpSpPr>
       <p:pic>
         <p:nvPicPr>
+          <p:cNvPr id="3" name="Picture 2">
+            <a:extLst>
+              <a:ext uri="{FF2B5EF4-FFF2-40B4-BE49-F238E27FC236}">
+                <a16:creationId xmlns:a16="http://schemas.microsoft.com/office/drawing/2014/main" id="{97479648-DD8F-E525-BDB3-EB159D57CFEE}"/>
+              </a:ext>
+            </a:extLst>
+          </p:cNvPr>
+          <p:cNvPicPr>
+            <a:picLocks noChangeAspect="1"/>
+          </p:cNvPicPr>
+          <p:nvPr/>
+        </p:nvPicPr>
+        <p:blipFill>
+          <a:blip r:embed="rId2"/>
+          <a:stretch>
+            <a:fillRect/>
+          </a:stretch>
+        </p:blipFill>
+        <p:spPr>
+          <a:xfrm>
+            <a:off x="319863" y="916453"/>
+            <a:ext cx="4896102" cy="3575234"/>
+          </a:xfrm>
+          <a:prstGeom prst="rect">
+            <a:avLst/>
+          </a:prstGeom>
+        </p:spPr>
+      </p:pic>
+    </p:spTree>
+    <p:extLst>
+      <p:ext uri="{BB962C8B-B14F-4D97-AF65-F5344CB8AC3E}">
+        <p14:creationId xmlns:p14="http://schemas.microsoft.com/office/powerpoint/2010/main" val="2466149437"/>
+      </p:ext>
+    </p:extLst>
+  </p:cSld>
+  <p:clrMapOvr>
+    <a:masterClrMapping/>
+  </p:clrMapOvr>
+</p:sld>
+</file>
+
+<file path=ppt/slides/slide3.xml><?xml version="1.0" encoding="utf-8"?>
+<p:sld xmlns:a="http://schemas.openxmlformats.org/drawingml/2006/main" xmlns:r="http://schemas.openxmlformats.org/officeDocument/2006/relationships" xmlns:p="http://schemas.openxmlformats.org/presentationml/2006/main">
+  <p:cSld>
+    <p:spTree>
+      <p:nvGrpSpPr>
+        <p:cNvPr id="1" name=""/>
+        <p:cNvGrpSpPr/>
+        <p:nvPr/>
+      </p:nvGrpSpPr>
+      <p:grpSpPr>
+        <a:xfrm>
+          <a:off x="0" y="0"/>
+          <a:ext cx="0" cy="0"/>
+          <a:chOff x="0" y="0"/>
+          <a:chExt cx="0" cy="0"/>
+        </a:xfrm>
+      </p:grpSpPr>
+      <p:pic>
+        <p:nvPicPr>
           <p:cNvPr id="5" name="Picture 4">
             <a:extLst>
               <a:ext uri="{FF2B5EF4-FFF2-40B4-BE49-F238E27FC236}">
@@ -5738,7 +5799,7 @@
 </p:sld>
 </file>
 
-<file path=ppt/slides/slide3.xml><?xml version="1.0" encoding="utf-8"?>
+<file path=ppt/slides/slide4.xml><?xml version="1.0" encoding="utf-8"?>
 <p:sld xmlns:a="http://schemas.openxmlformats.org/drawingml/2006/main" xmlns:r="http://schemas.openxmlformats.org/officeDocument/2006/relationships" xmlns:p="http://schemas.openxmlformats.org/presentationml/2006/main">
   <p:cSld>
     <p:spTree>
@@ -5827,7 +5888,7 @@
 </p:sld>
 </file>
 
-<file path=ppt/slides/slide4.xml><?xml version="1.0" encoding="utf-8"?>
+<file path=ppt/slides/slide5.xml><?xml version="1.0" encoding="utf-8"?>
 <p:sld xmlns:a="http://schemas.openxmlformats.org/drawingml/2006/main" xmlns:r="http://schemas.openxmlformats.org/officeDocument/2006/relationships" xmlns:p="http://schemas.openxmlformats.org/presentationml/2006/main">
   <p:cSld>
     <p:spTree>
@@ -5893,7 +5954,7 @@
 </p:sld>
 </file>
 
-<file path=ppt/slides/slide5.xml><?xml version="1.0" encoding="utf-8"?>
+<file path=ppt/slides/slide6.xml><?xml version="1.0" encoding="utf-8"?>
 <p:sld xmlns:a="http://schemas.openxmlformats.org/drawingml/2006/main" xmlns:r="http://schemas.openxmlformats.org/officeDocument/2006/relationships" xmlns:p="http://schemas.openxmlformats.org/presentationml/2006/main">
   <p:cSld>
     <p:spTree>
@@ -5959,7 +6020,7 @@
 </p:sld>
 </file>
 
-<file path=ppt/slides/slide6.xml><?xml version="1.0" encoding="utf-8"?>
+<file path=ppt/slides/slide7.xml><?xml version="1.0" encoding="utf-8"?>
 <p:sld xmlns:a="http://schemas.openxmlformats.org/drawingml/2006/main" xmlns:r="http://schemas.openxmlformats.org/officeDocument/2006/relationships" xmlns:p="http://schemas.openxmlformats.org/presentationml/2006/main">
   <p:cSld>
     <p:spTree>
@@ -6233,7 +6294,7 @@
 </p:sld>
 </file>
 
-<file path=ppt/slides/slide7.xml><?xml version="1.0" encoding="utf-8"?>
+<file path=ppt/slides/slide8.xml><?xml version="1.0" encoding="utf-8"?>
 <p:sld xmlns:a="http://schemas.openxmlformats.org/drawingml/2006/main" xmlns:r="http://schemas.openxmlformats.org/officeDocument/2006/relationships" xmlns:p="http://schemas.openxmlformats.org/presentationml/2006/main">
   <p:cSld>
     <p:spTree>
@@ -6493,7 +6554,7 @@
 </p:sld>
 </file>
 
-<file path=ppt/slides/slide8.xml><?xml version="1.0" encoding="utf-8"?>
+<file path=ppt/slides/slide9.xml><?xml version="1.0" encoding="utf-8"?>
 <p:sld xmlns:a="http://schemas.openxmlformats.org/drawingml/2006/main" xmlns:r="http://schemas.openxmlformats.org/officeDocument/2006/relationships" xmlns:p="http://schemas.openxmlformats.org/presentationml/2006/main">
   <p:cSld>
     <p:spTree>
@@ -8151,8 +8212,8 @@
           </p:sp>
         </mc:Fallback>
       </mc:AlternateContent>
-      <mc:AlternateContent xmlns:mc="http://schemas.openxmlformats.org/markup-compatibility/2006">
-        <mc:Choice xmlns:a14="http://schemas.microsoft.com/office/drawing/2010/main" Requires="a14">
+      <mc:AlternateContent xmlns:mc="http://schemas.openxmlformats.org/markup-compatibility/2006" xmlns:a14="http://schemas.microsoft.com/office/drawing/2010/main">
+        <mc:Choice Requires="a14">
           <p:graphicFrame>
             <p:nvGraphicFramePr>
               <p:cNvPr id="28" name="Table 27">
@@ -9407,7 +9468,7 @@
             </a:graphic>
           </p:graphicFrame>
         </mc:Choice>
-        <mc:Fallback>
+        <mc:Fallback xmlns="">
           <p:graphicFrame>
             <p:nvGraphicFramePr>
               <p:cNvPr id="28" name="Table 27">

</xml_diff>